<commit_message>
Refactor booking system to OOP + add CLI features
</commit_message>
<xml_diff>
--- a/Hotel Reservation Presentation.pptx
+++ b/Hotel Reservation Presentation.pptx
@@ -254,7 +254,7 @@
           <a:p>
             <a:fld id="{EF1077DB-935E-4A0A-947A-D283B9F9F452}" type="datetimeFigureOut">
               <a:rPr lang="en-US" smtClean="0"/>
-              <a:t>12/23/2025</a:t>
+              <a:t>12/24/2025</a:t>
             </a:fld>
             <a:endParaRPr lang="en-US" dirty="0"/>
           </a:p>
@@ -431,7 +431,7 @@
           <a:p>
             <a:fld id="{2D9EC30E-1A71-4188-9BE7-E2A64929A436}" type="datetimeFigureOut">
               <a:rPr lang="en-US" noProof="0" smtClean="0"/>
-              <a:t>12/23/2025</a:t>
+              <a:t>12/24/2025</a:t>
             </a:fld>
             <a:endParaRPr lang="en-US" noProof="0" dirty="0"/>
           </a:p>
@@ -7771,7 +7771,7 @@
                 </a:solidFill>
               </a:rPr>
               <a:pPr/>
-              <a:t>12/23/2025</a:t>
+              <a:t>12/24/2025</a:t>
             </a:fld>
             <a:endParaRPr lang="en-US" sz="1100" dirty="0">
               <a:solidFill>
@@ -8533,21 +8533,27 @@
             <p:ph type="title"/>
           </p:nvPr>
         </p:nvSpPr>
-        <p:spPr/>
+        <p:spPr>
+          <a:xfrm>
+            <a:off x="4096846" y="2576760"/>
+            <a:ext cx="4073101" cy="1695637"/>
+          </a:xfrm>
+        </p:spPr>
         <p:txBody>
           <a:bodyPr/>
           <a:lstStyle/>
           <a:p>
+            <a:pPr algn="ctr"/>
             <a:r>
               <a:rPr lang="en-US" sz="4800" dirty="0"/>
-              <a:t>Hotel</a:t>
+              <a:t>Hotel Booking</a:t>
             </a:r>
             <a:br>
               <a:rPr lang="en-US" sz="4800" dirty="0"/>
             </a:br>
             <a:r>
               <a:rPr lang="en-US" sz="4800" dirty="0"/>
-              <a:t>Reservation</a:t>
+              <a:t>System</a:t>
             </a:r>
             <a:endParaRPr lang="en-US" dirty="0"/>
           </a:p>
@@ -10840,16 +10846,18 @@
         <p:spPr>
           <a:xfrm>
             <a:off x="3352800" y="685800"/>
-            <a:ext cx="5486400" cy="5486400"/>
+            <a:ext cx="5577840" cy="5577840"/>
           </a:xfrm>
           <a:prstGeom prst="ellipse">
             <a:avLst/>
           </a:prstGeom>
-          <a:solidFill>
-            <a:schemeClr val="accent5">
-              <a:alpha val="40000"/>
-            </a:schemeClr>
-          </a:solidFill>
+          <a:blipFill dpi="0" rotWithShape="1">
+            <a:blip r:embed="rId3"/>
+            <a:srcRect/>
+            <a:stretch>
+              <a:fillRect l="-6558" t="-819" r="-4918" b="819"/>
+            </a:stretch>
+          </a:blipFill>
           <a:ln w="60325">
             <a:solidFill>
               <a:schemeClr val="bg1"/>
@@ -10897,7 +10905,12 @@
             <p:ph type="title"/>
           </p:nvPr>
         </p:nvSpPr>
-        <p:spPr/>
+        <p:spPr>
+          <a:xfrm>
+            <a:off x="4045678" y="2274444"/>
+            <a:ext cx="4007183" cy="2374194"/>
+          </a:xfrm>
+        </p:spPr>
         <p:txBody>
           <a:bodyPr/>
           <a:lstStyle/>
@@ -11624,11 +11637,6 @@
               </a:rPr>
               <a:t>Dr. Osama Ghoneim                                Eng. Omar Khaled</a:t>
             </a:r>
-            <a:endParaRPr lang="en-US" dirty="0">
-              <a:solidFill>
-                <a:srgbClr val="FA6F1A"/>
-              </a:solidFill>
-            </a:endParaRPr>
           </a:p>
         </p:txBody>
       </p:sp>
@@ -14146,24 +14154,6 @@
 </file>
 
 <file path=customXml/item1.xml><?xml version="1.0" encoding="utf-8"?>
-<p:properties xmlns:p="http://schemas.microsoft.com/office/2006/metadata/properties" xmlns:xsi="http://www.w3.org/2001/XMLSchema-instance" xmlns:pc="http://schemas.microsoft.com/office/infopath/2007/PartnerControls">
-  <documentManagement>
-    <Status xmlns="71af3243-3dd4-4a8d-8c0d-dd76da1f02a5">Not started</Status>
-    <MediaServiceKeyPoints xmlns="71af3243-3dd4-4a8d-8c0d-dd76da1f02a5" xsi:nil="true"/>
-  </documentManagement>
-</p:properties>
-</file>
-
-<file path=customXml/item2.xml><?xml version="1.0" encoding="utf-8"?>
-<?mso-contentType ?>
-<FormTemplates xmlns="http://schemas.microsoft.com/sharepoint/v3/contenttype/forms">
-  <Display>DocumentLibraryForm</Display>
-  <Edit>DocumentLibraryForm</Edit>
-  <New>DocumentLibraryForm</New>
-</FormTemplates>
-</file>
-
-<file path=customXml/item3.xml><?xml version="1.0" encoding="utf-8"?>
 <ct:contentTypeSchema xmlns:ct="http://schemas.microsoft.com/office/2006/metadata/contentType" xmlns:ma="http://schemas.microsoft.com/office/2006/metadata/properties/metaAttributes" ct:_="" ma:_="" ma:contentTypeName="Document" ma:contentTypeID="0x01010079F111ED35F8CC479449609E8A0923A6" ma:contentTypeVersion="12" ma:contentTypeDescription="Create a new document." ma:contentTypeScope="" ma:versionID="426e97fa315356fffbdcd9876fe988c2">
   <xsd:schema xmlns:xsd="http://www.w3.org/2001/XMLSchema" xmlns:xs="http://www.w3.org/2001/XMLSchema" xmlns:p="http://schemas.microsoft.com/office/2006/metadata/properties" xmlns:ns2="71af3243-3dd4-4a8d-8c0d-dd76da1f02a5" xmlns:ns3="16c05727-aa75-4e4a-9b5f-8a80a1165891" targetNamespace="http://schemas.microsoft.com/office/2006/metadata/properties" ma:root="true" ma:fieldsID="14b8f0def80e6d70ce3def20c90759ae" ns2:_="" ns3:_="">
     <xsd:import namespace="71af3243-3dd4-4a8d-8c0d-dd76da1f02a5"/>
@@ -14384,25 +14374,25 @@
 </ct:contentTypeSchema>
 </file>
 
-<file path=customXml/itemProps1.xml><?xml version="1.0" encoding="utf-8"?>
-<ds:datastoreItem xmlns:ds="http://schemas.openxmlformats.org/officeDocument/2006/customXml" ds:itemID="{4DEA9014-ED64-4558-B1E1-D03F0EE32BEB}">
-  <ds:schemaRefs>
-    <ds:schemaRef ds:uri="http://schemas.microsoft.com/office/2006/metadata/properties"/>
-    <ds:schemaRef ds:uri="http://schemas.microsoft.com/office/infopath/2007/PartnerControls"/>
-    <ds:schemaRef ds:uri="71af3243-3dd4-4a8d-8c0d-dd76da1f02a5"/>
-  </ds:schemaRefs>
-</ds:datastoreItem>
+<file path=customXml/item2.xml><?xml version="1.0" encoding="utf-8"?>
+<?mso-contentType ?>
+<FormTemplates xmlns="http://schemas.microsoft.com/sharepoint/v3/contenttype/forms">
+  <Display>DocumentLibraryForm</Display>
+  <Edit>DocumentLibraryForm</Edit>
+  <New>DocumentLibraryForm</New>
+</FormTemplates>
 </file>
 
-<file path=customXml/itemProps2.xml><?xml version="1.0" encoding="utf-8"?>
-<ds:datastoreItem xmlns:ds="http://schemas.openxmlformats.org/officeDocument/2006/customXml" ds:itemID="{05D99ABA-76CE-4A8E-B5F0-C051B96628DE}">
-  <ds:schemaRefs>
-    <ds:schemaRef ds:uri="http://schemas.microsoft.com/sharepoint/v3/contenttype/forms"/>
-  </ds:schemaRefs>
-</ds:datastoreItem>
+<file path=customXml/item3.xml><?xml version="1.0" encoding="utf-8"?>
+<p:properties xmlns:p="http://schemas.microsoft.com/office/2006/metadata/properties" xmlns:xsi="http://www.w3.org/2001/XMLSchema-instance" xmlns:pc="http://schemas.microsoft.com/office/infopath/2007/PartnerControls">
+  <documentManagement>
+    <Status xmlns="71af3243-3dd4-4a8d-8c0d-dd76da1f02a5">Not started</Status>
+    <MediaServiceKeyPoints xmlns="71af3243-3dd4-4a8d-8c0d-dd76da1f02a5" xsi:nil="true"/>
+  </documentManagement>
+</p:properties>
 </file>
 
-<file path=customXml/itemProps3.xml><?xml version="1.0" encoding="utf-8"?>
+<file path=customXml/itemProps1.xml><?xml version="1.0" encoding="utf-8"?>
 <ds:datastoreItem xmlns:ds="http://schemas.openxmlformats.org/officeDocument/2006/customXml" ds:itemID="{B19EB750-A6DA-4BE8-B87B-FC499FE73360}">
   <ds:schemaRefs>
     <ds:schemaRef ds:uri="http://schemas.microsoft.com/office/2006/metadata/contentType"/>
@@ -14419,4 +14409,22 @@
     <ds:schemaRef ds:uri="http://schemas.microsoft.com/internal/obd"/>
   </ds:schemaRefs>
 </ds:datastoreItem>
+</file>
+
+<file path=customXml/itemProps2.xml><?xml version="1.0" encoding="utf-8"?>
+<ds:datastoreItem xmlns:ds="http://schemas.openxmlformats.org/officeDocument/2006/customXml" ds:itemID="{05D99ABA-76CE-4A8E-B5F0-C051B96628DE}">
+  <ds:schemaRefs>
+    <ds:schemaRef ds:uri="http://schemas.microsoft.com/sharepoint/v3/contenttype/forms"/>
+  </ds:schemaRefs>
+</ds:datastoreItem>
+</file>
+
+<file path=customXml/itemProps3.xml><?xml version="1.0" encoding="utf-8"?>
+<ds:datastoreItem xmlns:ds="http://schemas.openxmlformats.org/officeDocument/2006/customXml" ds:itemID="{4DEA9014-ED64-4558-B1E1-D03F0EE32BEB}">
+  <ds:schemaRefs>
+    <ds:schemaRef ds:uri="http://schemas.microsoft.com/office/2006/metadata/properties"/>
+    <ds:schemaRef ds:uri="http://schemas.microsoft.com/office/infopath/2007/PartnerControls"/>
+    <ds:schemaRef ds:uri="71af3243-3dd4-4a8d-8c0d-dd76da1f02a5"/>
+  </ds:schemaRefs>
+</ds:datastoreItem>
 </file>
</xml_diff>